<commit_message>
fix: preserve presentation image aspect ratios
</commit_message>
<xml_diff>
--- a/presentations/NL-Resilience-Lab-overview.pptx
+++ b/presentations/NL-Resilience-Lab-overview.pptx
@@ -2431,7 +2431,7 @@
         </p:nvPicPr>
         <p:blipFill>
           <a:blip r:embed="rId1"/>
-          <a:srcRect l="0" r="0" t="0" b="0"/>
+          <a:srcRect l="32250" r="16250" t="0" b="0"/>
           <a:stretch/>
         </p:blipFill>
         <p:spPr>
@@ -13365,7 +13365,7 @@
         </p:nvPicPr>
         <p:blipFill>
           <a:blip r:embed="rId1"/>
-          <a:srcRect l="0" r="0" t="0" b="0"/>
+          <a:srcRect l="30061" r="10061" t="0" b="0"/>
           <a:stretch/>
         </p:blipFill>
         <p:spPr>
@@ -15773,7 +15773,7 @@
         </p:nvPicPr>
         <p:blipFill>
           <a:blip r:embed="rId1"/>
-          <a:srcRect l="0" r="0" t="0" b="0"/>
+          <a:srcRect l="3312" r="0" t="0" b="0"/>
           <a:stretch/>
         </p:blipFill>
         <p:spPr>
@@ -19143,6 +19143,31 @@
         </p:nvSpPr>
         <p:spPr>
           <a:xfrm>
+            <a:off x="2487168" y="3026664"/>
+            <a:ext cx="-292608" cy="-484632"/>
+          </a:xfrm>
+          <a:prstGeom prst="line">
+            <a:avLst/>
+          </a:prstGeom>
+          <a:noFill/>
+          <a:ln w="14605">
+            <a:solidFill>
+              <a:srgbClr val="294047"/>
+            </a:solidFill>
+            <a:prstDash val="solid"/>
+            <a:headEnd type="none"/>
+            <a:tailEnd type="triangle"/>
+          </a:ln>
+        </p:spPr>
+      </p:sp>
+      <p:sp>
+        <p:nvSpPr>
+          <p:cNvPr id="14" name="Shape 12"/>
+          <p:cNvSpPr/>
+          <p:nvPr/>
+        </p:nvSpPr>
+        <p:spPr>
+          <a:xfrm>
             <a:off x="640080" y="2066544"/>
             <a:ext cx="1554480" cy="566928"/>
           </a:xfrm>
@@ -19164,7 +19189,7 @@
       </p:sp>
       <p:sp>
         <p:nvSpPr>
-          <p:cNvPr id="14" name="Text 12"/>
+          <p:cNvPr id="15" name="Text 13"/>
           <p:cNvSpPr/>
           <p:nvPr/>
         </p:nvSpPr>
@@ -19205,7 +19230,7 @@
       </p:sp>
       <p:sp>
         <p:nvSpPr>
-          <p:cNvPr id="15" name="Text 13"/>
+          <p:cNvPr id="16" name="Text 14"/>
           <p:cNvSpPr/>
           <p:nvPr/>
         </p:nvSpPr>
@@ -19246,14 +19271,14 @@
       </p:sp>
       <p:sp>
         <p:nvSpPr>
-          <p:cNvPr id="16" name="Shape 14"/>
-          <p:cNvSpPr/>
-          <p:nvPr/>
-        </p:nvSpPr>
-        <p:spPr>
-          <a:xfrm>
-            <a:off x="2862072" y="3438144"/>
-            <a:ext cx="-667512" cy="-1088136"/>
+          <p:cNvPr id="17" name="Shape 15"/>
+          <p:cNvSpPr/>
+          <p:nvPr/>
+        </p:nvSpPr>
+        <p:spPr>
+          <a:xfrm>
+            <a:off x="3227832" y="3026664"/>
+            <a:ext cx="566928" cy="-484632"/>
           </a:xfrm>
           <a:prstGeom prst="line">
             <a:avLst/>
@@ -19271,7 +19296,7 @@
       </p:sp>
       <p:sp>
         <p:nvSpPr>
-          <p:cNvPr id="17" name="Shape 15"/>
+          <p:cNvPr id="18" name="Shape 16"/>
           <p:cNvSpPr/>
           <p:nvPr/>
         </p:nvSpPr>
@@ -19298,7 +19323,7 @@
       </p:sp>
       <p:sp>
         <p:nvSpPr>
-          <p:cNvPr id="18" name="Text 16"/>
+          <p:cNvPr id="19" name="Text 17"/>
           <p:cNvSpPr/>
           <p:nvPr/>
         </p:nvSpPr>
@@ -19339,7 +19364,7 @@
       </p:sp>
       <p:sp>
         <p:nvSpPr>
-          <p:cNvPr id="19" name="Text 17"/>
+          <p:cNvPr id="20" name="Text 18"/>
           <p:cNvSpPr/>
           <p:nvPr/>
         </p:nvSpPr>
@@ -19380,14 +19405,14 @@
       </p:sp>
       <p:sp>
         <p:nvSpPr>
-          <p:cNvPr id="20" name="Shape 18"/>
-          <p:cNvSpPr/>
-          <p:nvPr/>
-        </p:nvSpPr>
-        <p:spPr>
-          <a:xfrm>
-            <a:off x="2862072" y="3438144"/>
-            <a:ext cx="932688" cy="-1088136"/>
+          <p:cNvPr id="21" name="Shape 19"/>
+          <p:cNvSpPr/>
+          <p:nvPr/>
+        </p:nvSpPr>
+        <p:spPr>
+          <a:xfrm>
+            <a:off x="2487168" y="3877056"/>
+            <a:ext cx="-292608" cy="585216"/>
           </a:xfrm>
           <a:prstGeom prst="line">
             <a:avLst/>
@@ -19405,7 +19430,7 @@
       </p:sp>
       <p:sp>
         <p:nvSpPr>
-          <p:cNvPr id="21" name="Shape 19"/>
+          <p:cNvPr id="22" name="Shape 20"/>
           <p:cNvSpPr/>
           <p:nvPr/>
         </p:nvSpPr>
@@ -19432,7 +19457,7 @@
       </p:sp>
       <p:sp>
         <p:nvSpPr>
-          <p:cNvPr id="22" name="Text 20"/>
+          <p:cNvPr id="23" name="Text 21"/>
           <p:cNvSpPr/>
           <p:nvPr/>
         </p:nvSpPr>
@@ -19473,7 +19498,7 @@
       </p:sp>
       <p:sp>
         <p:nvSpPr>
-          <p:cNvPr id="23" name="Text 21"/>
+          <p:cNvPr id="24" name="Text 22"/>
           <p:cNvSpPr/>
           <p:nvPr/>
         </p:nvSpPr>
@@ -19514,14 +19539,14 @@
       </p:sp>
       <p:sp>
         <p:nvSpPr>
-          <p:cNvPr id="24" name="Shape 22"/>
-          <p:cNvSpPr/>
-          <p:nvPr/>
-        </p:nvSpPr>
-        <p:spPr>
-          <a:xfrm>
-            <a:off x="2862072" y="3438144"/>
-            <a:ext cx="-667512" cy="1106424"/>
+          <p:cNvPr id="25" name="Shape 23"/>
+          <p:cNvSpPr/>
+          <p:nvPr/>
+        </p:nvSpPr>
+        <p:spPr>
+          <a:xfrm>
+            <a:off x="3227832" y="3877056"/>
+            <a:ext cx="566928" cy="585216"/>
           </a:xfrm>
           <a:prstGeom prst="line">
             <a:avLst/>
@@ -19539,7 +19564,7 @@
       </p:sp>
       <p:sp>
         <p:nvSpPr>
-          <p:cNvPr id="25" name="Shape 23"/>
+          <p:cNvPr id="26" name="Shape 24"/>
           <p:cNvSpPr/>
           <p:nvPr/>
         </p:nvSpPr>
@@ -19566,7 +19591,7 @@
       </p:sp>
       <p:sp>
         <p:nvSpPr>
-          <p:cNvPr id="26" name="Text 24"/>
+          <p:cNvPr id="27" name="Text 25"/>
           <p:cNvSpPr/>
           <p:nvPr/>
         </p:nvSpPr>
@@ -19607,7 +19632,7 @@
       </p:sp>
       <p:sp>
         <p:nvSpPr>
-          <p:cNvPr id="27" name="Text 25"/>
+          <p:cNvPr id="28" name="Text 26"/>
           <p:cNvSpPr/>
           <p:nvPr/>
         </p:nvSpPr>
@@ -19648,14 +19673,14 @@
       </p:sp>
       <p:sp>
         <p:nvSpPr>
-          <p:cNvPr id="28" name="Shape 26"/>
-          <p:cNvSpPr/>
-          <p:nvPr/>
-        </p:nvSpPr>
-        <p:spPr>
-          <a:xfrm>
-            <a:off x="2862072" y="3438144"/>
-            <a:ext cx="932688" cy="1106424"/>
+          <p:cNvPr id="29" name="Shape 27"/>
+          <p:cNvSpPr/>
+          <p:nvPr/>
+        </p:nvSpPr>
+        <p:spPr>
+          <a:xfrm>
+            <a:off x="2862072" y="4023360"/>
+            <a:ext cx="128016" cy="987552"/>
           </a:xfrm>
           <a:prstGeom prst="line">
             <a:avLst/>
@@ -19673,7 +19698,7 @@
       </p:sp>
       <p:sp>
         <p:nvSpPr>
-          <p:cNvPr id="29" name="Shape 27"/>
+          <p:cNvPr id="30" name="Shape 28"/>
           <p:cNvSpPr/>
           <p:nvPr/>
         </p:nvSpPr>
@@ -19700,7 +19725,7 @@
       </p:sp>
       <p:sp>
         <p:nvSpPr>
-          <p:cNvPr id="30" name="Text 28"/>
+          <p:cNvPr id="31" name="Text 29"/>
           <p:cNvSpPr/>
           <p:nvPr/>
         </p:nvSpPr>
@@ -19741,7 +19766,7 @@
       </p:sp>
       <p:sp>
         <p:nvSpPr>
-          <p:cNvPr id="31" name="Text 29"/>
+          <p:cNvPr id="32" name="Text 30"/>
           <p:cNvSpPr/>
           <p:nvPr/>
         </p:nvSpPr>
@@ -19779,31 +19804,6 @@
             <a:endParaRPr lang="en-US" sz="750" dirty="0"/>
           </a:p>
         </p:txBody>
-      </p:sp>
-      <p:sp>
-        <p:nvSpPr>
-          <p:cNvPr id="32" name="Shape 30"/>
-          <p:cNvSpPr/>
-          <p:nvPr/>
-        </p:nvSpPr>
-        <p:spPr>
-          <a:xfrm>
-            <a:off x="2862072" y="3438144"/>
-            <a:ext cx="-649224" cy="1856232"/>
-          </a:xfrm>
-          <a:prstGeom prst="line">
-            <a:avLst/>
-          </a:prstGeom>
-          <a:noFill/>
-          <a:ln w="14605">
-            <a:solidFill>
-              <a:srgbClr val="294047"/>
-            </a:solidFill>
-            <a:prstDash val="solid"/>
-            <a:headEnd type="none"/>
-            <a:tailEnd type="triangle"/>
-          </a:ln>
-        </p:spPr>
       </p:sp>
       <p:sp>
         <p:nvSpPr>

</xml_diff>